<commit_message>
doc update, alternative wire formats
</commit_message>
<xml_diff>
--- a/platform/configuration/configuration.easy/src/test/easy/summary.pptx
+++ b/platform/configuration/configuration.easy/src/test/easy/summary.pptx
@@ -278,7 +278,7 @@
           <a:p>
             <a:fld id="{D5B82AE6-E612-48AC-BCA1-8D558D7A7716}" type="datetimeFigureOut">
               <a:rPr lang="en-DE" smtClean="0"/>
-              <a:t>07/12/2023</a:t>
+              <a:t>22/07/2026</a:t>
             </a:fld>
             <a:endParaRPr lang="en-DE"/>
           </a:p>
@@ -478,7 +478,7 @@
           <a:p>
             <a:fld id="{D5B82AE6-E612-48AC-BCA1-8D558D7A7716}" type="datetimeFigureOut">
               <a:rPr lang="en-DE" smtClean="0"/>
-              <a:t>07/12/2023</a:t>
+              <a:t>22/07/2026</a:t>
             </a:fld>
             <a:endParaRPr lang="en-DE"/>
           </a:p>
@@ -688,7 +688,7 @@
           <a:p>
             <a:fld id="{D5B82AE6-E612-48AC-BCA1-8D558D7A7716}" type="datetimeFigureOut">
               <a:rPr lang="en-DE" smtClean="0"/>
-              <a:t>07/12/2023</a:t>
+              <a:t>22/07/2026</a:t>
             </a:fld>
             <a:endParaRPr lang="en-DE"/>
           </a:p>
@@ -888,7 +888,7 @@
           <a:p>
             <a:fld id="{D5B82AE6-E612-48AC-BCA1-8D558D7A7716}" type="datetimeFigureOut">
               <a:rPr lang="en-DE" smtClean="0"/>
-              <a:t>07/12/2023</a:t>
+              <a:t>22/07/2026</a:t>
             </a:fld>
             <a:endParaRPr lang="en-DE"/>
           </a:p>
@@ -1164,7 +1164,7 @@
           <a:p>
             <a:fld id="{D5B82AE6-E612-48AC-BCA1-8D558D7A7716}" type="datetimeFigureOut">
               <a:rPr lang="en-DE" smtClean="0"/>
-              <a:t>07/12/2023</a:t>
+              <a:t>22/07/2026</a:t>
             </a:fld>
             <a:endParaRPr lang="en-DE"/>
           </a:p>
@@ -1432,7 +1432,7 @@
           <a:p>
             <a:fld id="{D5B82AE6-E612-48AC-BCA1-8D558D7A7716}" type="datetimeFigureOut">
               <a:rPr lang="en-DE" smtClean="0"/>
-              <a:t>07/12/2023</a:t>
+              <a:t>22/07/2026</a:t>
             </a:fld>
             <a:endParaRPr lang="en-DE"/>
           </a:p>
@@ -1847,7 +1847,7 @@
           <a:p>
             <a:fld id="{D5B82AE6-E612-48AC-BCA1-8D558D7A7716}" type="datetimeFigureOut">
               <a:rPr lang="en-DE" smtClean="0"/>
-              <a:t>07/12/2023</a:t>
+              <a:t>22/07/2026</a:t>
             </a:fld>
             <a:endParaRPr lang="en-DE"/>
           </a:p>
@@ -1989,7 +1989,7 @@
           <a:p>
             <a:fld id="{D5B82AE6-E612-48AC-BCA1-8D558D7A7716}" type="datetimeFigureOut">
               <a:rPr lang="en-DE" smtClean="0"/>
-              <a:t>07/12/2023</a:t>
+              <a:t>22/07/2026</a:t>
             </a:fld>
             <a:endParaRPr lang="en-DE"/>
           </a:p>
@@ -2102,7 +2102,7 @@
           <a:p>
             <a:fld id="{D5B82AE6-E612-48AC-BCA1-8D558D7A7716}" type="datetimeFigureOut">
               <a:rPr lang="en-DE" smtClean="0"/>
-              <a:t>07/12/2023</a:t>
+              <a:t>22/07/2026</a:t>
             </a:fld>
             <a:endParaRPr lang="en-DE"/>
           </a:p>
@@ -2415,7 +2415,7 @@
           <a:p>
             <a:fld id="{D5B82AE6-E612-48AC-BCA1-8D558D7A7716}" type="datetimeFigureOut">
               <a:rPr lang="en-DE" smtClean="0"/>
-              <a:t>07/12/2023</a:t>
+              <a:t>22/07/2026</a:t>
             </a:fld>
             <a:endParaRPr lang="en-DE"/>
           </a:p>
@@ -2704,7 +2704,7 @@
           <a:p>
             <a:fld id="{D5B82AE6-E612-48AC-BCA1-8D558D7A7716}" type="datetimeFigureOut">
               <a:rPr lang="en-DE" smtClean="0"/>
-              <a:t>07/12/2023</a:t>
+              <a:t>22/07/2026</a:t>
             </a:fld>
             <a:endParaRPr lang="en-DE"/>
           </a:p>
@@ -2947,7 +2947,7 @@
           <a:p>
             <a:fld id="{D5B82AE6-E612-48AC-BCA1-8D558D7A7716}" type="datetimeFigureOut">
               <a:rPr lang="en-DE" smtClean="0"/>
-              <a:t>07/12/2023</a:t>
+              <a:t>22/07/2026</a:t>
             </a:fld>
             <a:endParaRPr lang="en-DE"/>
           </a:p>
@@ -4487,10 +4487,37 @@
               <a:t>asynchronous</a:t>
             </a:r>
             <a:r>
-              <a:rPr lang="de-DE"/>
-              <a:t> paths</a:t>
+              <a:rPr lang="de-DE" dirty="0"/>
+              <a:t> </a:t>
+            </a:r>
+            <a:r>
+              <a:rPr lang="de-DE" dirty="0" err="1"/>
+              <a:t>paths</a:t>
             </a:r>
             <a:endParaRPr lang="de-DE" dirty="0"/>
+          </a:p>
+          <a:p>
+            <a:pPr lvl="1"/>
+            <a:r>
+              <a:rPr lang="de-DE" dirty="0"/>
+              <a:t>Transport </a:t>
+            </a:r>
+            <a:r>
+              <a:rPr lang="de-DE" dirty="0" err="1"/>
+              <a:t>wire</a:t>
+            </a:r>
+            <a:r>
+              <a:rPr lang="de-DE" dirty="0"/>
+              <a:t> </a:t>
+            </a:r>
+            <a:r>
+              <a:rPr lang="de-DE" dirty="0" err="1"/>
+              <a:t>format</a:t>
+            </a:r>
+            <a:r>
+              <a:rPr lang="de-DE" dirty="0"/>
+              <a:t>: JSON</a:t>
+            </a:r>
           </a:p>
           <a:p>
             <a:r>
@@ -6568,6 +6595,34 @@
             <a:endParaRPr lang="de-DE" dirty="0"/>
           </a:p>
           <a:p>
+            <a:pPr lvl="1"/>
+            <a:r>
+              <a:rPr lang="de-DE" dirty="0"/>
+              <a:t>Transport </a:t>
+            </a:r>
+            <a:r>
+              <a:rPr lang="de-DE" dirty="0" err="1"/>
+              <a:t>wire</a:t>
+            </a:r>
+            <a:r>
+              <a:rPr lang="de-DE" dirty="0"/>
+              <a:t> </a:t>
+            </a:r>
+            <a:r>
+              <a:rPr lang="de-DE" dirty="0" err="1"/>
+              <a:t>format</a:t>
+            </a:r>
+            <a:r>
+              <a:rPr lang="de-DE" dirty="0"/>
+              <a:t>: </a:t>
+            </a:r>
+            <a:r>
+              <a:rPr lang="de-DE" dirty="0" err="1"/>
+              <a:t>Protobuf</a:t>
+            </a:r>
+            <a:endParaRPr lang="de-DE" dirty="0"/>
+          </a:p>
+          <a:p>
             <a:r>
               <a:rPr lang="de-DE" dirty="0" err="1"/>
               <a:t>Purely</a:t>
@@ -7773,6 +7828,29 @@
               <a:t>connectors</a:t>
             </a:r>
             <a:endParaRPr lang="de-DE" dirty="0"/>
+          </a:p>
+          <a:p>
+            <a:pPr lvl="1"/>
+            <a:r>
+              <a:rPr lang="de-DE" dirty="0"/>
+              <a:t>Transport </a:t>
+            </a:r>
+            <a:r>
+              <a:rPr lang="de-DE" dirty="0" err="1"/>
+              <a:t>wire</a:t>
+            </a:r>
+            <a:r>
+              <a:rPr lang="de-DE" dirty="0"/>
+              <a:t> </a:t>
+            </a:r>
+            <a:r>
+              <a:rPr lang="de-DE" dirty="0" err="1"/>
+              <a:t>format</a:t>
+            </a:r>
+            <a:r>
+              <a:rPr lang="de-DE" dirty="0"/>
+              <a:t>: JSON</a:t>
+            </a:r>
           </a:p>
           <a:p>
             <a:r>
@@ -9809,7 +9887,7 @@
               <a:t>generating</a:t>
             </a:r>
             <a:r>
-              <a:rPr lang="de-DE"/>
+              <a:rPr lang="de-DE" dirty="0"/>
               <a:t> a </a:t>
             </a:r>
             <a:r>
@@ -9920,6 +9998,30 @@
             <a:r>
               <a:rPr lang="de-DE" dirty="0" err="1"/>
               <a:t>chain</a:t>
+            </a:r>
+            <a:endParaRPr lang="de-DE" dirty="0"/>
+          </a:p>
+          <a:p>
+            <a:pPr lvl="1"/>
+            <a:r>
+              <a:rPr lang="de-DE" dirty="0"/>
+              <a:t>Transport </a:t>
+            </a:r>
+            <a:r>
+              <a:rPr lang="de-DE" dirty="0" err="1"/>
+              <a:t>wire</a:t>
+            </a:r>
+            <a:r>
+              <a:rPr lang="de-DE" dirty="0"/>
+              <a:t> </a:t>
+            </a:r>
+            <a:r>
+              <a:rPr lang="de-DE" dirty="0" err="1"/>
+              <a:t>format</a:t>
+            </a:r>
+            <a:r>
+              <a:rPr lang="de-DE"/>
+              <a:t>: XML</a:t>
             </a:r>
             <a:endParaRPr lang="de-DE" dirty="0"/>
           </a:p>
@@ -13106,6 +13208,29 @@
             <a:endParaRPr lang="de-DE" dirty="0"/>
           </a:p>
           <a:p>
+            <a:pPr lvl="1"/>
+            <a:r>
+              <a:rPr lang="de-DE" dirty="0"/>
+              <a:t>Transport </a:t>
+            </a:r>
+            <a:r>
+              <a:rPr lang="de-DE" dirty="0" err="1"/>
+              <a:t>wire</a:t>
+            </a:r>
+            <a:r>
+              <a:rPr lang="de-DE" dirty="0"/>
+              <a:t> </a:t>
+            </a:r>
+            <a:r>
+              <a:rPr lang="de-DE" dirty="0" err="1"/>
+              <a:t>format</a:t>
+            </a:r>
+            <a:r>
+              <a:rPr lang="de-DE" dirty="0"/>
+              <a:t>: JSON</a:t>
+            </a:r>
+          </a:p>
+          <a:p>
             <a:r>
               <a:rPr lang="de-DE" dirty="0" err="1"/>
               <a:t>Used</a:t>
@@ -13169,6 +13294,22 @@
                 <a:latin typeface="Consolas" panose="020B0609020204030204" pitchFamily="49" charset="0"/>
               </a:rPr>
               <a:t>examples</a:t>
+            </a:r>
+            <a:r>
+              <a:rPr lang="de-DE" dirty="0"/>
+              <a:t> and in </a:t>
+            </a:r>
+            <a:r>
+              <a:rPr lang="de-DE" dirty="0" err="1">
+                <a:latin typeface="Consolas" panose="020B0609020204030204" pitchFamily="49" charset="0"/>
+              </a:rPr>
+              <a:t>managementUI</a:t>
+            </a:r>
+            <a:r>
+              <a:rPr lang="de-DE" dirty="0">
+                <a:latin typeface="Consolas" panose="020B0609020204030204" pitchFamily="49" charset="0"/>
+              </a:rPr>
+              <a:t>.</a:t>
             </a:r>
             <a:endParaRPr lang="en-DE" dirty="0">
               <a:latin typeface="Consolas" panose="020B0609020204030204" pitchFamily="49" charset="0"/>
@@ -14076,7 +14217,7 @@
             </a:r>
             <a:r>
               <a:rPr lang="de-DE" i="1" dirty="0"/>
-              <a:t> UI.</a:t>
+              <a:t> UI. </a:t>
             </a:r>
             <a:endParaRPr lang="en-DE" i="1" dirty="0"/>
           </a:p>
@@ -14916,6 +15057,29 @@
               <a:t>communication</a:t>
             </a:r>
             <a:endParaRPr lang="de-DE" dirty="0"/>
+          </a:p>
+          <a:p>
+            <a:pPr lvl="1"/>
+            <a:r>
+              <a:rPr lang="de-DE" dirty="0"/>
+              <a:t>Transport </a:t>
+            </a:r>
+            <a:r>
+              <a:rPr lang="de-DE" dirty="0" err="1"/>
+              <a:t>wire</a:t>
+            </a:r>
+            <a:r>
+              <a:rPr lang="de-DE" dirty="0"/>
+              <a:t> </a:t>
+            </a:r>
+            <a:r>
+              <a:rPr lang="de-DE" dirty="0" err="1"/>
+              <a:t>format</a:t>
+            </a:r>
+            <a:r>
+              <a:rPr lang="de-DE" dirty="0"/>
+              <a:t>: JSON</a:t>
+            </a:r>
           </a:p>
           <a:p>
             <a:r>

</xml_diff>